<commit_message>
Correct two documented example rows and declare numpy
The user guide quoted the confidence for the wrong direction of a pair (0.66 is blue to pink; pink to blue is 0.85), and the workshop example was not a row the pipeline produces. Both now use rows taken from the current output, with the best-seller effect illustrated by a product that really is recommended for 69 others. Also declares numpy, which was imported but not listed, and drops an unused constant.
</commit_message>
<xml_diff>
--- a/workshop/ai_literacy_workshop.pptx
+++ b/workshop/ai_literacy_workshop.pptx
@@ -1891,7 +1891,7 @@
                 <a:ea typeface="Calibri" pitchFamily="34" charset="-122"/>
                 <a:cs typeface="Calibri" pitchFamily="34" charset="-120"/>
               </a:rPr>
-              <a:t>A real row from the live tool</a:t>
+              <a:t>A real row from the live tool - every number below is from the current table</a:t>
             </a:r>
             <a:endParaRPr lang="en-US" sz="1500" dirty="0"/>
           </a:p>
@@ -1933,23 +1933,23 @@
         <p:spPr>
           <a:xfrm>
             <a:off x="1005840" y="2148840"/>
-            <a:ext cx="6217920" cy="411480"/>
-          </a:xfrm>
-          <a:prstGeom prst="rect">
-            <a:avLst/>
-          </a:prstGeom>
-          <a:noFill/>
-          <a:ln/>
-        </p:spPr>
-        <p:txBody>
-          <a:bodyPr wrap="square" lIns="0" tIns="0" rIns="0" bIns="0" rtlCol="0" anchor="ctr"/>
-          <a:lstStyle/>
-          <a:p>
-            <a:pPr indent="0" marL="0">
-              <a:buNone/>
-            </a:pPr>
-            <a:r>
-              <a:rPr lang="en-US" sz="1700" b="1" dirty="0">
+            <a:ext cx="6217920" cy="640080"/>
+          </a:xfrm>
+          <a:prstGeom prst="rect">
+            <a:avLst/>
+          </a:prstGeom>
+          <a:noFill/>
+          <a:ln/>
+        </p:spPr>
+        <p:txBody>
+          <a:bodyPr wrap="square" lIns="0" tIns="0" rIns="0" bIns="0" rtlCol="0" anchor="ctr"/>
+          <a:lstStyle/>
+          <a:p>
+            <a:pPr indent="0" marL="0">
+              <a:buNone/>
+            </a:pPr>
+            <a:r>
+              <a:rPr lang="en-US" sz="1600" b="1" dirty="0">
                 <a:solidFill>
                   <a:srgbClr val="0B0B0B"/>
                 </a:solidFill>
@@ -1957,9 +1957,9 @@
                 <a:ea typeface="Calibri" pitchFamily="34" charset="-122"/>
                 <a:cs typeface="Calibri" pitchFamily="34" charset="-120"/>
               </a:rPr>
-              <a:t>SEASONAL BEST-SELLER  →  ALMOST EVERYTHING</a:t>
-            </a:r>
-            <a:endParaRPr lang="en-US" sz="1700" dirty="0"/>
+              <a:t>WHITE METAL LANTERN  →  WHITE HANGING HEART T-LIGHT HOLDER</a:t>
+            </a:r>
+            <a:endParaRPr lang="en-US" sz="1600" dirty="0"/>
           </a:p>
         </p:txBody>
       </p:sp>
@@ -1971,7 +1971,7 @@
         </p:nvSpPr>
         <p:spPr>
           <a:xfrm>
-            <a:off x="1005840" y="2880360"/>
+            <a:off x="1005840" y="2926080"/>
             <a:ext cx="6217920" cy="320040"/>
           </a:xfrm>
           <a:prstGeom prst="rect">
@@ -1996,7 +1996,7 @@
                 <a:ea typeface="Calibri" pitchFamily="34" charset="-122"/>
                 <a:cs typeface="Calibri" pitchFamily="34" charset="-120"/>
               </a:rPr>
-              <a:t>Confidence 0.44</a:t>
+              <a:t>63 baskets, confidence 0.28, lift 2.70</a:t>
             </a:r>
             <a:pPr indent="0" marL="0">
               <a:buNone/>
@@ -2010,7 +2010,7 @@
                 <a:ea typeface="Calibri" pitchFamily="34" charset="-122"/>
                 <a:cs typeface="Calibri" pitchFamily="34" charset="-120"/>
               </a:rPr>
-              <a:t>   —   looks convincing</a:t>
+              <a:t>   —   looks like a finding</a:t>
             </a:r>
             <a:endParaRPr lang="en-US" sz="1500" dirty="0"/>
           </a:p>
@@ -2024,7 +2024,60 @@
         </p:nvSpPr>
         <p:spPr>
           <a:xfrm>
-            <a:off x="1005840" y="3337560"/>
+            <a:off x="1005840" y="3383280"/>
+            <a:ext cx="6217920" cy="640080"/>
+          </a:xfrm>
+          <a:prstGeom prst="rect">
+            <a:avLst/>
+          </a:prstGeom>
+          <a:noFill/>
+          <a:ln/>
+        </p:spPr>
+        <p:txBody>
+          <a:bodyPr wrap="square" lIns="0" tIns="0" rIns="0" bIns="0" rtlCol="0" anchor="ctr"/>
+          <a:lstStyle/>
+          <a:p>
+            <a:pPr indent="0" marL="0">
+              <a:buNone/>
+            </a:pPr>
+            <a:r>
+              <a:rPr lang="en-US" sz="1500" dirty="0">
+                <a:solidFill>
+                  <a:srgbClr val="52514E"/>
+                </a:solidFill>
+                <a:latin typeface="Calibri" pitchFamily="34" charset="0"/>
+                <a:ea typeface="Calibri" pitchFamily="34" charset="-122"/>
+                <a:cs typeface="Calibri" pitchFamily="34" charset="-120"/>
+              </a:rPr>
+              <a:t>...until you notice</a:t>
+            </a:r>
+            <a:pPr indent="0" marL="0">
+              <a:buNone/>
+            </a:pPr>
+            <a:r>
+              <a:rPr lang="en-US" sz="1500" b="1" dirty="0">
+                <a:solidFill>
+                  <a:srgbClr val="D03B3B"/>
+                </a:solidFill>
+                <a:latin typeface="Calibri" pitchFamily="34" charset="0"/>
+                <a:ea typeface="Calibri" pitchFamily="34" charset="-122"/>
+                <a:cs typeface="Calibri" pitchFamily="34" charset="-120"/>
+              </a:rPr>
+              <a:t> the same t-light holder is recommended for 69 other products</a:t>
+            </a:r>
+            <a:endParaRPr lang="en-US" sz="1500" dirty="0"/>
+          </a:p>
+        </p:txBody>
+      </p:sp>
+      <p:sp>
+        <p:nvSpPr>
+          <p:cNvPr id="8" name="Text 6"/>
+          <p:cNvSpPr/>
+          <p:nvPr/>
+        </p:nvSpPr>
+        <p:spPr>
+          <a:xfrm>
+            <a:off x="1005840" y="4069080"/>
             <a:ext cx="6217920" cy="320040"/>
           </a:xfrm>
           <a:prstGeom prst="rect">
@@ -2041,20 +2094,6 @@
               <a:buNone/>
             </a:pPr>
             <a:r>
-              <a:rPr lang="en-US" sz="1500" b="1" dirty="0">
-                <a:solidFill>
-                  <a:srgbClr val="D03B3B"/>
-                </a:solidFill>
-                <a:latin typeface="Calibri" pitchFamily="34" charset="0"/>
-                <a:ea typeface="Calibri" pitchFamily="34" charset="-122"/>
-                <a:cs typeface="Calibri" pitchFamily="34" charset="-120"/>
-              </a:rPr>
-              <a:t>Lift 1.1</a:t>
-            </a:r>
-            <a:pPr indent="0" marL="0">
-              <a:buNone/>
-            </a:pPr>
-            <a:r>
               <a:rPr lang="en-US" sz="1500" dirty="0">
                 <a:solidFill>
                   <a:srgbClr val="52514E"/>
@@ -2063,46 +2102,7 @@
                 <a:ea typeface="Calibri" pitchFamily="34" charset="-122"/>
                 <a:cs typeface="Calibri" pitchFamily="34" charset="-120"/>
               </a:rPr>
-              <a:t>   —   no more likely than chance</a:t>
-            </a:r>
-            <a:endParaRPr lang="en-US" sz="1500" dirty="0"/>
-          </a:p>
-        </p:txBody>
-      </p:sp>
-      <p:sp>
-        <p:nvSpPr>
-          <p:cNvPr id="8" name="Text 6"/>
-          <p:cNvSpPr/>
-          <p:nvPr/>
-        </p:nvSpPr>
-        <p:spPr>
-          <a:xfrm>
-            <a:off x="1005840" y="3794760"/>
-            <a:ext cx="6217920" cy="320040"/>
-          </a:xfrm>
-          <a:prstGeom prst="rect">
-            <a:avLst/>
-          </a:prstGeom>
-          <a:noFill/>
-          <a:ln/>
-        </p:spPr>
-        <p:txBody>
-          <a:bodyPr wrap="square" lIns="0" tIns="0" rIns="0" bIns="0" rtlCol="0" anchor="ctr"/>
-          <a:lstStyle/>
-          <a:p>
-            <a:pPr indent="0" marL="0">
-              <a:buNone/>
-            </a:pPr>
-            <a:r>
-              <a:rPr lang="en-US" sz="1500" dirty="0">
-                <a:solidFill>
-                  <a:srgbClr val="52514E"/>
-                </a:solidFill>
-                <a:latin typeface="Calibri" pitchFamily="34" charset="0"/>
-                <a:ea typeface="Calibri" pitchFamily="34" charset="-122"/>
-                <a:cs typeface="Calibri" pitchFamily="34" charset="-120"/>
-              </a:rPr>
-              <a:t>410 baskets</a:t>
+              <a:t>It is in a large share of every basket, so it pairs with everything.</a:t>
             </a:r>
             <a:endParaRPr lang="en-US" sz="1500" dirty="0"/>
           </a:p>
@@ -2207,7 +2207,7 @@
                 <a:ea typeface="Calibri" pitchFamily="34" charset="-122"/>
                 <a:cs typeface="Calibri" pitchFamily="34" charset="-120"/>
               </a:rPr>
-              <a:t>Every number here is real.</a:t>
+              <a:t>Every number here is from the live table.</a:t>
             </a:r>
             <a:endParaRPr lang="en-US" sz="1400" dirty="0"/>
           </a:p>
@@ -2230,7 +2230,7 @@
                 <a:ea typeface="Calibri" pitchFamily="34" charset="-122"/>
                 <a:cs typeface="Calibri" pitchFamily="34" charset="-120"/>
               </a:rPr>
-              <a:t>By 0:30 you'll be able to say in one sentence why this row is worthless.</a:t>
+              <a:t>By 0:30 you'll be able to say in one sentence why this row is weak.</a:t>
             </a:r>
             <a:endParaRPr lang="en-US" sz="1400" dirty="0"/>
           </a:p>
@@ -2269,7 +2269,7 @@
                 <a:ea typeface="Calibri" pitchFamily="34" charset="-122"/>
                 <a:cs typeface="Calibri" pitchFamily="34" charset="-120"/>
               </a:rPr>
-              <a:t>Confidence is the number people read. Lift is the number that decides.</a:t>
+              <a:t>Popularity is not affinity. Always ask what else that product is recommended for.</a:t>
             </a:r>
             <a:endParaRPr lang="en-US" sz="1600" dirty="0"/>
           </a:p>
@@ -2676,7 +2676,7 @@
                 <a:ea typeface="Calibri" pitchFamily="34" charset="-122"/>
                 <a:cs typeface="Calibri" pitchFamily="34" charset="-120"/>
               </a:rPr>
-              <a:t>0.66</a:t>
+              <a:t>0.85</a:t>
             </a:r>
             <a:endParaRPr lang="en-US" sz="4600" dirty="0"/>
           </a:p>
@@ -2754,7 +2754,7 @@
                 <a:ea typeface="Calibri" pitchFamily="34" charset="-122"/>
                 <a:cs typeface="Calibri" pitchFamily="34" charset="-120"/>
               </a:rPr>
-              <a:t>Of baskets with the pink spade, 66% also had the blue one.</a:t>
+              <a:t>Of baskets with the pink spade, 85% also had the blue one.</a:t>
             </a:r>
             <a:endParaRPr lang="en-US" sz="1300" dirty="0"/>
           </a:p>
@@ -2937,7 +2937,7 @@
                 <a:ea typeface="Calibri" pitchFamily="34" charset="-122"/>
                 <a:cs typeface="Calibri" pitchFamily="34" charset="-120"/>
               </a:rPr>
-              <a:t>Back to the bad row: confidence 0.44, lift 1.1. Lift near 1 means "chance". That's the whole answer.</a:t>
+              <a:t>Back to the first row: lift 2.7 against 234 here. Same catalogue, two very different kinds of evidence.</a:t>
             </a:r>
             <a:endParaRPr lang="en-US" sz="1500" dirty="0"/>
           </a:p>

</xml_diff>

<commit_message>
Address verified portfolio audit findings
</commit_message>
<xml_diff>
--- a/workshop/ai_literacy_workshop.pptx
+++ b/workshop/ai_literacy_workshop.pptx
@@ -1758,6 +1758,9 @@
       <a:noFill/>
     </a:ln>
   </c:spPr>
+  <c:externalData xmlns:ns0="http://schemas.openxmlformats.org/officeDocument/2006/relationships" ns0:id="rId1">
+    <c:autoUpdate val="0"/>
+  </c:externalData>
 </c:chartSpace>
 </file>
 
@@ -2072,7 +2075,7 @@
                 <a:ea typeface="Calibri"/>
                 <a:cs typeface="Calibri"/>
               </a:rPr>
-              <a:t>A row from the simulated adoption table - every number below is generated test data</a:t>
+              <a:t>A recommendation from the live table, computed from the retail dataset</a:t>
             </a:r>
             <a:endParaRPr sz="1500"/>
           </a:p>
@@ -2199,7 +2202,7 @@
                 <a:ea typeface="Calibri"/>
                 <a:cs typeface="Calibri"/>
               </a:rPr>
-              <a:t>63 baskets, confidence 0.28, lift 2.70</a:t>
+              <a:t>63 baskets, confidence 0.19, lift 1.65</a:t>
             </a:r>
             <a:r>
               <a:rPr sz="1500">
@@ -2267,7 +2270,7 @@
                 <a:ea typeface="Calibri"/>
                 <a:cs typeface="Calibri"/>
               </a:rPr>
-              <a:t> the same t-light holder is recommended for 69 other products</a:t>
+              <a:t> the same t-light holder is recommended for 79 products</a:t>
             </a:r>
             <a:endParaRPr sz="1500"/>
           </a:p>
@@ -2980,7 +2983,7 @@
                 <a:ea typeface="Calibri"/>
                 <a:cs typeface="Calibri"/>
               </a:rPr>
-              <a:t>0.85</a:t>
+              <a:t>0.48</a:t>
             </a:r>
             <a:endParaRPr sz="4600"/>
           </a:p>
@@ -3072,7 +3075,7 @@
                 <a:ea typeface="Calibri"/>
                 <a:cs typeface="Calibri"/>
               </a:rPr>
-              <a:t>Of baskets with the pink spade, 85% also had the blue one.</a:t>
+              <a:t>Of baskets with the pink spade, 48% also had the blue one.</a:t>
             </a:r>
             <a:endParaRPr sz="1300"/>
           </a:p>
@@ -3153,7 +3156,7 @@
                 <a:ea typeface="Calibri"/>
                 <a:cs typeface="Calibri"/>
               </a:rPr>
-              <a:t>234</a:t>
+              <a:t>95</a:t>
             </a:r>
             <a:endParaRPr sz="4600"/>
           </a:p>
@@ -3245,7 +3248,7 @@
                 <a:ea typeface="Calibri"/>
                 <a:cs typeface="Calibri"/>
               </a:rPr>
-              <a:t>234× more likely than chance. This is the ranking column.</a:t>
+              <a:t>95× the independent-purchase expectation. This is the ranking column.</a:t>
             </a:r>
             <a:endParaRPr sz="1300"/>
           </a:p>
@@ -3291,7 +3294,7 @@
                 <a:ea typeface="Calibri"/>
                 <a:cs typeface="Calibri"/>
               </a:rPr>
-              <a:t>Back to the first row: lift 2.7 against 234 here. Same catalogue, two very different kinds of evidence.</a:t>
+              <a:t>Back to the first row: lift 1.65 against 95 here. Same catalogue, different strengths of association.</a:t>
             </a:r>
             <a:endParaRPr sz="1500"/>
           </a:p>
@@ -4627,7 +4630,7 @@
                 <a:ea typeface="Cambria"/>
                 <a:cs typeface="Cambria"/>
               </a:rPr>
-              <a:t>How it's going, and one ask</a:t>
+              <a:t>Reading the simulated adoption report</a:t>
             </a:r>
             <a:endParaRPr sz="3400"/>
           </a:p>
@@ -4770,7 +4773,7 @@
                 <a:ea typeface="Calibri"/>
                 <a:cs typeface="Calibri"/>
               </a:rPr>
-              <a:t>Weeks 3 and 8 are these workshops</a:t>
+              <a:t>Illustrative workshop dates</a:t>
             </a:r>
             <a:endParaRPr sz="1600"/>
           </a:p>
@@ -4816,7 +4819,7 @@
                 <a:ea typeface="Calibri"/>
                 <a:cs typeface="Calibri"/>
               </a:rPr>
-              <a:t>16% → 34% after the first.</a:t>
+              <a:t>These changes are generated examples.</a:t>
             </a:r>
             <a:endParaRPr sz="1350"/>
           </a:p>
@@ -4833,7 +4836,7 @@
                 <a:ea typeface="Calibri"/>
                 <a:cs typeface="Calibri"/>
               </a:rPr>
-              <a:t>27% → 44% after the second.</a:t>
+              <a:t>They do not measure workshop impact.</a:t>
             </a:r>
             <a:endParaRPr sz="1350"/>
           </a:p>
@@ -4856,7 +4859,7 @@
                 <a:ea typeface="Calibri"/>
                 <a:cs typeface="Calibri"/>
               </a:rPr>
-              <a:t>Both held rather than decaying — which is the part that matters. A spike that decays means people looked once.</a:t>
+              <a:t>With real telemetry, check sustained use, missing data and a comparison group before attributing change to training.</a:t>
             </a:r>
             <a:endParaRPr sz="1350"/>
           </a:p>
@@ -4902,7 +4905,7 @@
                 <a:ea typeface="Calibri"/>
                 <a:cs typeface="Calibri"/>
               </a:rPr>
-              <a:t>One ask: use it once this week on a real decision, and tell us what happened. The feedback button is two clicks.</a:t>
+              <a:t>Exercise: identify the evidence needed to distinguish sustained use from a short-lived spike.</a:t>
             </a:r>
             <a:endParaRPr sz="1600"/>
           </a:p>

</xml_diff>

<commit_message>
Validate retail metrics, documentation and temporal recommendations
Apply verified portfolio corrections and reproducible evidence.
</commit_message>
<xml_diff>
--- a/workshop/ai_literacy_workshop.pptx
+++ b/workshop/ai_literacy_workshop.pptx
@@ -1758,6 +1758,9 @@
       <a:noFill/>
     </a:ln>
   </c:spPr>
+  <c:externalData xmlns:ns0="http://schemas.openxmlformats.org/officeDocument/2006/relationships" ns0:id="rId1">
+    <c:autoUpdate val="0"/>
+  </c:externalData>
 </c:chartSpace>
 </file>
 
@@ -2072,7 +2075,7 @@
                 <a:ea typeface="Calibri"/>
                 <a:cs typeface="Calibri"/>
               </a:rPr>
-              <a:t>A row from the simulated adoption table - every number below is generated test data</a:t>
+              <a:t>A recommendation from the live table, computed from the retail dataset</a:t>
             </a:r>
             <a:endParaRPr sz="1500"/>
           </a:p>
@@ -2199,7 +2202,7 @@
                 <a:ea typeface="Calibri"/>
                 <a:cs typeface="Calibri"/>
               </a:rPr>
-              <a:t>63 baskets, confidence 0.28, lift 2.70</a:t>
+              <a:t>63 baskets, confidence 0.19, lift 1.65</a:t>
             </a:r>
             <a:r>
               <a:rPr sz="1500">
@@ -2267,7 +2270,7 @@
                 <a:ea typeface="Calibri"/>
                 <a:cs typeface="Calibri"/>
               </a:rPr>
-              <a:t> the same t-light holder is recommended for 69 other products</a:t>
+              <a:t> the same t-light holder is recommended for 79 products</a:t>
             </a:r>
             <a:endParaRPr sz="1500"/>
           </a:p>
@@ -2980,7 +2983,7 @@
                 <a:ea typeface="Calibri"/>
                 <a:cs typeface="Calibri"/>
               </a:rPr>
-              <a:t>0.85</a:t>
+              <a:t>0.48</a:t>
             </a:r>
             <a:endParaRPr sz="4600"/>
           </a:p>
@@ -3072,7 +3075,7 @@
                 <a:ea typeface="Calibri"/>
                 <a:cs typeface="Calibri"/>
               </a:rPr>
-              <a:t>Of baskets with the pink spade, 85% also had the blue one.</a:t>
+              <a:t>Of baskets with the pink spade, 48% also had the blue one.</a:t>
             </a:r>
             <a:endParaRPr sz="1300"/>
           </a:p>
@@ -3153,7 +3156,7 @@
                 <a:ea typeface="Calibri"/>
                 <a:cs typeface="Calibri"/>
               </a:rPr>
-              <a:t>234</a:t>
+              <a:t>95</a:t>
             </a:r>
             <a:endParaRPr sz="4600"/>
           </a:p>
@@ -3245,7 +3248,7 @@
                 <a:ea typeface="Calibri"/>
                 <a:cs typeface="Calibri"/>
               </a:rPr>
-              <a:t>234× more likely than chance. This is the ranking column.</a:t>
+              <a:t>95× the independent-purchase expectation. This is the ranking column.</a:t>
             </a:r>
             <a:endParaRPr sz="1300"/>
           </a:p>
@@ -3291,7 +3294,7 @@
                 <a:ea typeface="Calibri"/>
                 <a:cs typeface="Calibri"/>
               </a:rPr>
-              <a:t>Back to the first row: lift 2.7 against 234 here. Same catalogue, two very different kinds of evidence.</a:t>
+              <a:t>Back to the first row: lift 1.65 against 95 here. Same catalogue, different strengths of association.</a:t>
             </a:r>
             <a:endParaRPr sz="1500"/>
           </a:p>
@@ -4627,7 +4630,7 @@
                 <a:ea typeface="Cambria"/>
                 <a:cs typeface="Cambria"/>
               </a:rPr>
-              <a:t>How it's going, and one ask</a:t>
+              <a:t>Reading the simulated adoption report</a:t>
             </a:r>
             <a:endParaRPr sz="3400"/>
           </a:p>
@@ -4770,7 +4773,7 @@
                 <a:ea typeface="Calibri"/>
                 <a:cs typeface="Calibri"/>
               </a:rPr>
-              <a:t>Weeks 3 and 8 are these workshops</a:t>
+              <a:t>Illustrative workshop dates</a:t>
             </a:r>
             <a:endParaRPr sz="1600"/>
           </a:p>
@@ -4816,7 +4819,7 @@
                 <a:ea typeface="Calibri"/>
                 <a:cs typeface="Calibri"/>
               </a:rPr>
-              <a:t>16% → 34% after the first.</a:t>
+              <a:t>These changes are generated examples.</a:t>
             </a:r>
             <a:endParaRPr sz="1350"/>
           </a:p>
@@ -4833,7 +4836,7 @@
                 <a:ea typeface="Calibri"/>
                 <a:cs typeface="Calibri"/>
               </a:rPr>
-              <a:t>27% → 44% after the second.</a:t>
+              <a:t>They do not measure workshop impact.</a:t>
             </a:r>
             <a:endParaRPr sz="1350"/>
           </a:p>
@@ -4856,7 +4859,7 @@
                 <a:ea typeface="Calibri"/>
                 <a:cs typeface="Calibri"/>
               </a:rPr>
-              <a:t>Both held rather than decaying — which is the part that matters. A spike that decays means people looked once.</a:t>
+              <a:t>With real telemetry, check sustained use, missing data and a comparison group before attributing change to training.</a:t>
             </a:r>
             <a:endParaRPr sz="1350"/>
           </a:p>
@@ -4902,7 +4905,7 @@
                 <a:ea typeface="Calibri"/>
                 <a:cs typeface="Calibri"/>
               </a:rPr>
-              <a:t>One ask: use it once this week on a real decision, and tell us what happened. The feedback button is two clicks.</a:t>
+              <a:t>Exercise: identify the evidence needed to distinguish sustained use from a short-lived spike.</a:t>
             </a:r>
             <a:endParaRPr sz="1600"/>
           </a:p>

</xml_diff>